<commit_message>
Replace Part 3 (SDEs) deck with updated version
</commit_message>
<xml_diff>
--- a/diffusion/score_sde_part3_polished.pptx
+++ b/diffusion/score_sde_part3_polished.pptx
@@ -3318,7 +3318,7 @@
         </p:nvSpPr>
         <p:spPr>
           <a:xfrm>
-            <a:off x="3813048" y="4434840"/>
+            <a:off x="3813048" y="4297680"/>
             <a:ext cx="4572000" cy="914400"/>
           </a:xfrm>
           <a:prstGeom prst="roundRect">
@@ -3381,7 +3381,7 @@
         </p:blipFill>
         <p:spPr>
           <a:xfrm>
-            <a:off x="4230352" y="4716463"/>
+            <a:off x="4230352" y="4579303"/>
             <a:ext cx="3730990" cy="351152"/>
           </a:xfrm>
           <a:prstGeom prst="rect">
@@ -3397,8 +3397,8 @@
         </p:nvSpPr>
         <p:spPr>
           <a:xfrm>
-            <a:off x="0" y="6035040"/>
-            <a:ext cx="12191695" cy="320040"/>
+            <a:off x="0" y="5669280"/>
+            <a:ext cx="12191695" cy="365760"/>
           </a:xfrm>
           <a:prstGeom prst="rect">
             <a:avLst/>
@@ -3413,13 +3413,48 @@
           <a:p>
             <a:pPr algn="ctr"/>
             <a:r>
-              <a:rPr sz="1200" b="0" i="0" spc="100">
+              <a:rPr sz="1600" b="1" i="0">
+                <a:solidFill>
+                  <a:srgbClr val="1B1F2A"/>
+                </a:solidFill>
+                <a:latin typeface="Arial"/>
+              </a:rPr>
+              <a:t>Sudarshan Babu</a:t>
+            </a:r>
+          </a:p>
+        </p:txBody>
+      </p:sp>
+      <p:sp>
+        <p:nvSpPr>
+          <p:cNvPr id="9" name="TextBox 8"/>
+          <p:cNvSpPr txBox="1"/>
+          <p:nvPr/>
+        </p:nvSpPr>
+        <p:spPr>
+          <a:xfrm>
+            <a:off x="0" y="6144768"/>
+            <a:ext cx="12191695" cy="274320"/>
+          </a:xfrm>
+          <a:prstGeom prst="rect">
+            <a:avLst/>
+          </a:prstGeom>
+          <a:noFill/>
+        </p:spPr>
+        <p:txBody>
+          <a:bodyPr wrap="square" anchor="t" lIns="0" rIns="0" tIns="0" bIns="0">
+            <a:spAutoFit/>
+          </a:bodyPr>
+          <a:lstStyle/>
+          <a:p>
+            <a:pPr algn="ctr"/>
+            <a:r>
+              <a:rPr sz="1050" b="0" i="1">
                 <a:solidFill>
                   <a:srgbClr val="8A909C"/>
                 </a:solidFill>
                 <a:latin typeface="Arial"/>
               </a:rPr>
-              <a:t>February 2026</a:t>
+              <a:t>Slides created using Claude and Manus AI — each slide was prompted by the author.</a:t>
             </a:r>
           </a:p>
         </p:txBody>

</xml_diff>